<commit_message>
Rebuild thesis PDF and defense slides without the EMA study
109-page PDF + 27-slide deck rebuilt via build_thesis.ps1 -Target all
-Release; build log clean (no undefined macros/references).

Co-Authored-By: Claude Fable 5 <noreply@anthropic.com>
</commit_message>
<xml_diff>
--- a/publications/thesis/releases/AutoShotV2_Defense.pptx
+++ b/publications/thesis/releases/AutoShotV2_Defense.pptx
@@ -9754,7 +9754,7 @@
                 </a:solidFill>
                 <a:latin typeface="Calibri"/>
               </a:rPr>
-              <a:t>EMA </a:t>
+              <a:t>Early stopping </a:t>
             </a:r>
             <a:r>
               <a:rPr sz="1400">
@@ -9763,7 +9763,7 @@
                 </a:solidFill>
                 <a:latin typeface="Calibri"/>
               </a:rPr>
-              <a:t>cho loss và trọng số → ổn định.</a:t>
+              <a:t>theo F1 trên validation.</a:t>
             </a:r>
           </a:p>
           <a:p>
@@ -9791,43 +9791,6 @@
                 </a:solidFill>
                 <a:latin typeface="Calibri"/>
               </a:rPr>
-              <a:t>Early stopping </a:t>
-            </a:r>
-            <a:r>
-              <a:rPr sz="1400">
-                <a:solidFill>
-                  <a:srgbClr val="1F2A44"/>
-                </a:solidFill>
-                <a:latin typeface="Calibri"/>
-              </a:rPr>
-              <a:t>theo F1 trên validation.</a:t>
-            </a:r>
-          </a:p>
-          <a:p>
-            <a:pPr algn="l">
-              <a:lnSpc>
-                <a:spcPct val="135000"/>
-              </a:lnSpc>
-              <a:spcAft>
-                <a:spcPts val="400"/>
-              </a:spcAft>
-            </a:pPr>
-            <a:r>
-              <a:rPr sz="1400" b="1">
-                <a:solidFill>
-                  <a:srgbClr val="0B5FFF"/>
-                </a:solidFill>
-                <a:latin typeface="Calibri"/>
-              </a:rPr>
-              <a:t>•  </a:t>
-            </a:r>
-            <a:r>
-              <a:rPr sz="1400" b="1">
-                <a:solidFill>
-                  <a:srgbClr val="1F2A44"/>
-                </a:solidFill>
-                <a:latin typeface="Calibri"/>
-              </a:rPr>
               <a:t>Focal Loss + Many-hot labels </a:t>
             </a:r>
             <a:r>
@@ -10565,7 +10528,7 @@
                 </a:solidFill>
                 <a:latin typeface="Calibri"/>
               </a:rPr>
-              <a:t>EMA</a:t>
+              <a:t>Head size</a:t>
             </a:r>
           </a:p>
         </p:txBody>
@@ -10579,120 +10542,6 @@
         <p:spPr>
           <a:xfrm>
             <a:off x="9418320" y="4864608"/>
-            <a:ext cx="2103120" cy="365760"/>
-          </a:xfrm>
-          <a:prstGeom prst="rect">
-            <a:avLst/>
-          </a:prstGeom>
-          <a:noFill/>
-        </p:spPr>
-        <p:txBody>
-          <a:bodyPr wrap="square" lIns="0" rIns="0" tIns="0" bIns="0" anchor="t">
-            <a:spAutoFit/>
-          </a:bodyPr>
-          <a:lstStyle/>
-          <a:p>
-            <a:pPr algn="l"/>
-            <a:r>
-              <a:rPr sz="1300" b="1">
-                <a:solidFill>
-                  <a:srgbClr val="0B5FFF"/>
-                </a:solidFill>
-                <a:latin typeface="Calibri"/>
-              </a:rPr>
-              <a:t>Bật</a:t>
-            </a:r>
-          </a:p>
-        </p:txBody>
-      </p:sp>
-      <p:sp>
-        <p:nvSpPr>
-          <p:cNvPr id="34" name="Rectangle 33"/>
-          <p:cNvSpPr/>
-          <p:nvPr/>
-        </p:nvSpPr>
-        <p:spPr>
-          <a:xfrm>
-            <a:off x="6400800" y="5257800"/>
-            <a:ext cx="5212080" cy="502920"/>
-          </a:xfrm>
-          <a:prstGeom prst="rect">
-            <a:avLst/>
-          </a:prstGeom>
-          <a:solidFill>
-            <a:srgbClr val="F4F6F8"/>
-          </a:solidFill>
-          <a:ln>
-            <a:noFill/>
-          </a:ln>
-          <a:effectLst/>
-        </p:spPr>
-        <p:style>
-          <a:lnRef idx="1">
-            <a:schemeClr val="accent1"/>
-          </a:lnRef>
-          <a:fillRef idx="3">
-            <a:schemeClr val="accent1"/>
-          </a:fillRef>
-          <a:effectRef idx="2">
-            <a:schemeClr val="accent1"/>
-          </a:effectRef>
-          <a:fontRef idx="minor">
-            <a:schemeClr val="lt1"/>
-          </a:fontRef>
-        </p:style>
-        <p:txBody>
-          <a:bodyPr rtlCol="0" anchor="ctr" lIns="0" rIns="0"/>
-          <a:lstStyle/>
-          <a:p>
-            <a:pPr algn="ctr"/>
-          </a:p>
-        </p:txBody>
-      </p:sp>
-      <p:sp>
-        <p:nvSpPr>
-          <p:cNvPr id="35" name="TextBox 34"/>
-          <p:cNvSpPr txBox="1"/>
-          <p:nvPr/>
-        </p:nvSpPr>
-        <p:spPr>
-          <a:xfrm>
-            <a:off x="6629400" y="5367528"/>
-            <a:ext cx="2743200" cy="365760"/>
-          </a:xfrm>
-          <a:prstGeom prst="rect">
-            <a:avLst/>
-          </a:prstGeom>
-          <a:noFill/>
-        </p:spPr>
-        <p:txBody>
-          <a:bodyPr wrap="square" lIns="0" rIns="0" tIns="0" bIns="0" anchor="t">
-            <a:spAutoFit/>
-          </a:bodyPr>
-          <a:lstStyle/>
-          <a:p>
-            <a:pPr algn="l"/>
-            <a:r>
-              <a:rPr sz="1300" b="0">
-                <a:solidFill>
-                  <a:srgbClr val="1F2A44"/>
-                </a:solidFill>
-                <a:latin typeface="Calibri"/>
-              </a:rPr>
-              <a:t>Head size</a:t>
-            </a:r>
-          </a:p>
-        </p:txBody>
-      </p:sp>
-      <p:sp>
-        <p:nvSpPr>
-          <p:cNvPr id="36" name="TextBox 35"/>
-          <p:cNvSpPr txBox="1"/>
-          <p:nvPr/>
-        </p:nvSpPr>
-        <p:spPr>
-          <a:xfrm>
-            <a:off x="9418320" y="5367528"/>
             <a:ext cx="2103120" cy="365760"/>
           </a:xfrm>
           <a:prstGeom prst="rect">

</xml_diff>

<commit_message>
docs: rebuild thesis PDF and defense slides (fixed table format and removed EMA)
</commit_message>
<xml_diff>
--- a/publications/thesis/releases/AutoShotV2_Defense.pptx
+++ b/publications/thesis/releases/AutoShotV2_Defense.pptx
@@ -18371,7 +18371,7 @@
         <p:spPr>
           <a:xfrm>
             <a:off x="7955280" y="3840480"/>
-            <a:ext cx="2543396" cy="457200"/>
+            <a:ext cx="2544349" cy="457200"/>
           </a:xfrm>
           <a:prstGeom prst="rect">
             <a:avLst/>
@@ -18414,7 +18414,7 @@
         </p:nvSpPr>
         <p:spPr>
           <a:xfrm>
-            <a:off x="10590116" y="3950208"/>
+            <a:off x="10591069" y="3950208"/>
             <a:ext cx="731520" cy="457200"/>
           </a:xfrm>
           <a:prstGeom prst="rect">
@@ -20515,7 +20515,7 @@
                 </a:solidFill>
                 <a:latin typeface="Calibri"/>
               </a:rPr>
-              <a:t>Giảm trên ClipShots (−3.1%): </a:t>
+              <a:t>Giảm trên ClipShots (−3.4%): </a:t>
             </a:r>
             <a:r>
               <a:rPr sz="1300">
@@ -23653,7 +23653,7 @@
                 </a:solidFill>
                 <a:latin typeface="Calibri"/>
               </a:rPr>
-              <a:t>Cấu hình tối ưu cho SHOT giảm F1 trên ClipShots −3.1pp; recall gradual chỉ 4.4% là nút thắt chính.</a:t>
+              <a:t>Cấu hình tối ưu cho SHOT giảm F1 trên ClipShots −3.4pp; recall gradual chỉ 4.4% là nút thắt chính.</a:t>
             </a:r>
           </a:p>
         </p:txBody>

</xml_diff>